<commit_message>
Consistency: exercise numbers, a slide note about removed pictures, and names on the Command slides
Co-Authored-By: Claude Opus 5.5 <noreply@anthropic.com>
Claude-Session: https://claude.ai/code/session_012sjsUQBbC7zon57rWHoo9d
</commit_message>
<xml_diff>
--- a/slides/04 Sokoban.pptx
+++ b/slides/04 Sokoban.pptx
@@ -11677,7 +11677,7 @@
                 <a:cs typeface="Consolas"/>
                 <a:sym typeface="Consolas"/>
               </a:rPr>
-              <a:t>FireGun</a:t>
+              <a:t>Fire</a:t>
             </a:r>
             <a:r>
               <a:rPr lang="en" sz="1000">
@@ -11999,7 +11999,7 @@
                 <a:cs typeface="Consolas"/>
                 <a:sym typeface="Consolas"/>
               </a:rPr>
-              <a:t>Lurch</a:t>
+              <a:t>Dodge</a:t>
             </a:r>
             <a:r>
               <a:rPr lang="en" sz="1000">
@@ -13416,7 +13416,7 @@
                 <a:cs typeface="Consolas"/>
                 <a:sym typeface="Consolas"/>
               </a:rPr>
-              <a:t>LurchCommand</a:t>
+              <a:t>DodgeCommand</a:t>
             </a:r>
             <a:r>
               <a:rPr lang="en" sz="1000">

</xml_diff>